<commit_message>
docs: v0.1.1 — denetim düzeltmeleri, lisans metinleri, güncel yatırımcı sunumu
- Test sayıları CI ile aynı (877+4 atlanan; yerelde 879+2), rozet "877 backend + 79 frontend".
- must_keep: 8 iş teriminin 90 geçişi; korunan 10 geçiş "Ödeme Planı".
- Veri klasörü ve uv/Python yerleri doğru; geliştirici araçları önerisi için Vazgeç notu.
- 11 Ekim canlı DMG denemesi "Ne denendi" bölümünde; denenmeyenler açıkça yazılı.
- THIRD_PARTY_LICENSES: React, React Router, TanStack Query MIT metinleri.
- SECURITY.md bildirim bölümü; .gitattributes ile archive/ dil istatistiğinden çıktı.
- Yatırımcı sunumu: kurumsal dil, lokal LLM, Claude ve ChatGPT, gerçek kurumsal örnek,
  Screenwall Claude / Screenwall ChatGPT; tasarım değişmedi (yedek repo dışında).

Co-Authored-By: Claude Opus 5.5 <noreply@anthropic.com>
</commit_message>
<xml_diff>
--- a/Screenwall-Yatirimci-Sunum.pptx
+++ b/Screenwall-Yatirimci-Sunum.pptx
@@ -4365,7 +4365,7 @@
                 </a:solidFill>
                 <a:latin typeface="Avenir Next"/>
               </a:rPr>
-              <a:t>Hassas belgelerinizle, en güçlü yapay zekâ modellerini güvenle kullanmanın yolu.</a:t>
+              <a:t>Şirket dokümanlarınızla Claude'u ve ChatGPT'yi güvenle kullanmanın yolu.</a:t>
             </a:r>
           </a:p>
         </p:txBody>
@@ -4883,7 +4883,7 @@
                 </a:solidFill>
                 <a:latin typeface="Avenir Next"/>
               </a:rPr>
-              <a:t>Yerel denetçi dahil, dil modelleri yalnız maskelenmiş kopyayı görür.</a:t>
+              <a:t>Lokal LLM dahil, dil modelleri yalnız maskelenmiş kopyayı görür.</a:t>
             </a:r>
           </a:p>
         </p:txBody>
@@ -4971,7 +4971,7 @@
                 </a:solidFill>
                 <a:latin typeface="Avenir Next"/>
               </a:rPr>
-              <a:t>İsteğe bağlı: Claude, Codex</a:t>
+              <a:t>İsteğe bağlı: Claude, ChatGPT</a:t>
             </a:r>
           </a:p>
           <a:p>
@@ -4983,7 +4983,7 @@
                 </a:solidFill>
                 <a:latin typeface="Avenir Next"/>
               </a:rPr>
-              <a:t>Sizin CLI girişinizle çalışır; Screenwall API anahtarı saklamaz.</a:t>
+              <a:t>Kendi Claude Code / Codex CLI girişinizle çalışır; Screenwall API anahtarı saklamaz.</a:t>
             </a:r>
           </a:p>
         </p:txBody>
@@ -5266,7 +5266,7 @@
                 </a:solidFill>
                 <a:latin typeface="Avenir Next"/>
               </a:rPr>
-              <a:t>Doğruluk cevap anahtarlı 240 sentetik belgede, dayanıklılık 72 tuzaklı dosyada ölçülür; 30 gerçek BIST belgesinde yalnız maskeleme oranına bakılır. Listeler kapalı; kıyas korpusu repoda yok.</a:t>
+              <a:t>Doğruluk cevap anahtarlı 240 sentetik belgede, dayanıklılık 72 tuzaklı dosyada ölçülür; listeler kapalı, kıyas korpusu repoda yok. 60 belgelik geliştirme seti kural ayarında da kullanıldı; mühürlü test seti henüz yok.</a:t>
             </a:r>
           </a:p>
         </p:txBody>
@@ -5392,7 +5392,7 @@
                 </a:solidFill>
                 <a:latin typeface="Avenir Next"/>
               </a:rPr>
-              <a:t>Kritik veri yakalama — 60 belge, listeler kapalı</a:t>
+              <a:t>Kritik veri yakalama — 60 belgelik geliştirme seti</a:t>
             </a:r>
           </a:p>
         </p:txBody>
@@ -5686,7 +5686,7 @@
                 </a:solidFill>
                 <a:latin typeface="Avenir Next"/>
               </a:rPr>
-              <a:t>879 + 79 yeşil</a:t>
+              <a:t>877 + 79 yeşil (CI)</a:t>
             </a:r>
           </a:p>
         </p:txBody>
@@ -5728,7 +5728,7 @@
                 </a:solidFill>
                 <a:latin typeface="Avenir Next"/>
               </a:rPr>
-              <a:t>Şüphede sistem onaylamaz, belge insana düşer — güvenlik ayar değil, varsayılan.</a:t>
+              <a:t>Şüphede sistem onaylamaz, karar kullanıcıya kalır — güvenlik ayar değil, varsayılan.</a:t>
             </a:r>
           </a:p>
         </p:txBody>
@@ -5997,7 +5997,7 @@
                 </a:solidFill>
                 <a:latin typeface="Avenir Next"/>
               </a:rPr>
-              <a:t>İki sistem de aynı puanlayıcıyla (Sol'un kendi puanlayıcısı), aynı korpusla ve hiçbir terim listesi olmadan koşuldu.</a:t>
+              <a:t>Biri Claude ile, diğeri ChatGPT (Codex) ile geliştirilen iki sürüm; aynı puanlayıcı (ChatGPT sürümününki), aynı korpus, listesiz.</a:t>
             </a:r>
           </a:p>
           <a:p>
@@ -6016,7 +6016,7 @@
                 </a:solidFill>
                 <a:latin typeface="Avenir Next"/>
               </a:rPr>
-              <a:t>Sol, Fable'ın bir kopyasıyla başladı ve motorunu değiştirdi. Kıyas korpusu repoda yok.</a:t>
+              <a:t>ChatGPT sürümü, Claude sürümünün bir kopyasıyla başladı ve tespit motorunu değiştirdi. Kıyas korpusu repoda yok.</a:t>
             </a:r>
           </a:p>
         </p:txBody>
@@ -6095,7 +6095,7 @@
             </a:pPr>
             <a:r>
               <a:rPr lang="en-US" dirty="0"/>
-              <a:t>Fable</a:t>
+              <a:t>Screenwall Claude</a:t>
             </a:r>
             <a:endParaRPr dirty="0"/>
           </a:p>
@@ -6133,7 +6133,7 @@
             </a:pPr>
             <a:r>
               <a:rPr dirty="0"/>
-              <a:t>Sol</a:t>
+              <a:t>Screenwall ChatGPT</a:t>
             </a:r>
           </a:p>
         </p:txBody>
@@ -6553,7 +6553,7 @@
                 </a:solidFill>
                 <a:latin typeface="Avenir Next"/>
               </a:rPr>
-              <a:t>Korunan iş terimi (yüksek iyi)</a:t>
+              <a:t>Korunan iş terimi (8 terim, 90 geçiş)</a:t>
             </a:r>
           </a:p>
         </p:txBody>
@@ -6637,7 +6637,7 @@
                 </a:solidFill>
                 <a:latin typeface="Avenir Next"/>
               </a:rPr>
-              <a:t>38/90 — Sol önde</a:t>
+              <a:t>38/90 — ChatGPT sürümü önde</a:t>
             </a:r>
           </a:p>
         </p:txBody>
@@ -6805,7 +6805,7 @@
                 </a:solidFill>
                 <a:latin typeface="Avenir Next"/>
               </a:rPr>
-              <a:t>Dürüstlük notu: önceki sürümdeki “0/90” bir test sızıntısıydı (liste, ölçülen 90 terimin hepsini içeriyordu); dürüst sayı 10/90.</a:t>
+              <a:t>Dürüstlük notu: önceki sürümdeki “0/90” bir test sızıntısıydı (liste, ölçülen 8 terimin hepsini içeriyordu); dürüst sayı 10/90.</a:t>
             </a:r>
           </a:p>
           <a:p>
@@ -6824,7 +6824,7 @@
                 </a:solidFill>
                 <a:latin typeface="Avenir Next"/>
               </a:rPr>
-              <a:t>İş terimlerini korumada Sol önde; sıradaki hedefimiz bu. Stres testinde ikisi de 0/72 sızıntı.</a:t>
+              <a:t>İş terimlerini korumada ChatGPT sürümü önde; sıradaki hedefimiz bu. Stres testinde ikisi de 0/72 sızıntı.</a:t>
             </a:r>
           </a:p>
           <a:p>
@@ -6843,7 +6843,7 @@
                 </a:solidFill>
                 <a:latin typeface="Avenir Next"/>
               </a:rPr>
-              <a:t>Kod adı: Fable — github.com/EminKolac/screenwall</a:t>
+              <a:t>Screenwall Claude kaynak kodu: github.com/EminKolac/screenwall</a:t>
             </a:r>
           </a:p>
         </p:txBody>
@@ -7377,7 +7377,7 @@
                 </a:solidFill>
                 <a:latin typeface="Avenir Next"/>
               </a:rPr>
-              <a:t>listesiz, yüksek iyi</a:t>
+              <a:t>8 terim, 90 geçiş; listesiz, yüksek iyi</a:t>
             </a:r>
           </a:p>
         </p:txBody>
@@ -8184,7 +8184,7 @@
                 </a:solidFill>
                 <a:latin typeface="Avenir Next"/>
               </a:rPr>
-              <a:t>Hassas belgelerinizle, en güçlü yapay zekâ modellerini güvenle kullanmanın yolu.</a:t>
+              <a:t>Şirket dokümanlarınızla Claude'u ve ChatGPT'yi güvenle kullanmanın yolu.</a:t>
             </a:r>
           </a:p>
         </p:txBody>
@@ -8641,7 +8641,7 @@
                 </a:solidFill>
                 <a:latin typeface="Avenir Next"/>
               </a:rPr>
-              <a:t>Kişisel</a:t>
+              <a:t>Hassas</a:t>
             </a:r>
             <a:r>
               <a:rPr lang="en-US" sz="1150" b="1" i="0" dirty="0">
@@ -8659,7 +8659,7 @@
                 </a:solidFill>
                 <a:latin typeface="Avenir Next"/>
               </a:rPr>
-              <a:t>veri</a:t>
+              <a:t>bilgi</a:t>
             </a:r>
             <a:r>
               <a:rPr lang="en-US" sz="1150" b="1" i="0" dirty="0">
@@ -8695,7 +8695,7 @@
                 </a:solidFill>
                 <a:latin typeface="Avenir Next"/>
               </a:rPr>
-              <a:t>belge</a:t>
+              <a:t>doküman</a:t>
             </a:r>
             <a:endParaRPr sz="1150" b="1" i="0" dirty="0">
               <a:solidFill>
@@ -8856,7 +8856,7 @@
                 </a:solidFill>
                 <a:latin typeface="Avenir Next"/>
               </a:rPr>
-              <a:t>Kişisel veri kurum dışına çıkar</a:t>
+              <a:t>Hassas bilgi kurum dışına çıkar</a:t>
             </a:r>
           </a:p>
         </p:txBody>
@@ -9172,7 +9172,7 @@
                 </a:solidFill>
                 <a:latin typeface="Avenir Next"/>
               </a:rPr>
-              <a:t>Kişisel</a:t>
+              <a:t>Hassas</a:t>
             </a:r>
             <a:r>
               <a:rPr lang="en-US" sz="1150" b="1" dirty="0">
@@ -9190,7 +9190,7 @@
                 </a:solidFill>
                 <a:latin typeface="Avenir Next"/>
               </a:rPr>
-              <a:t>veri</a:t>
+              <a:t>bilgi</a:t>
             </a:r>
             <a:r>
               <a:rPr lang="en-US" sz="1150" b="1" dirty="0">
@@ -9226,7 +9226,7 @@
                 </a:solidFill>
                 <a:latin typeface="Avenir Next"/>
               </a:rPr>
-              <a:t>belge</a:t>
+              <a:t>doküman</a:t>
             </a:r>
             <a:endParaRPr lang="en-US" sz="1150" b="1" dirty="0">
               <a:solidFill>
@@ -9703,7 +9703,7 @@
                 </a:solidFill>
                 <a:latin typeface="Avenir Next"/>
               </a:rPr>
-              <a:t>Kişisel</a:t>
+              <a:t>Hassas</a:t>
             </a:r>
             <a:r>
               <a:rPr lang="en-US" sz="1150" b="1" dirty="0">
@@ -9721,7 +9721,7 @@
                 </a:solidFill>
                 <a:latin typeface="Avenir Next"/>
               </a:rPr>
-              <a:t>veri</a:t>
+              <a:t>bilgi</a:t>
             </a:r>
             <a:r>
               <a:rPr lang="en-US" sz="1150" b="1" dirty="0">
@@ -9757,7 +9757,7 @@
                 </a:solidFill>
                 <a:latin typeface="Avenir Next"/>
               </a:rPr>
-              <a:t>belge</a:t>
+              <a:t>doküman</a:t>
             </a:r>
             <a:endParaRPr lang="en-US" sz="1150" b="1" dirty="0">
               <a:solidFill>
@@ -9918,7 +9918,7 @@
                 </a:solidFill>
                 <a:latin typeface="Avenir Next"/>
               </a:rPr>
-              <a:t>Kişisel veri belgeden ayrılır,
+              <a:t>Hassas bilgi dokümandan ayrılır,
 yerine anonim etiketler geçer</a:t>
             </a:r>
           </a:p>
@@ -10075,7 +10075,7 @@
                 </a:solidFill>
                 <a:latin typeface="Avenir Next"/>
               </a:rPr>
-              <a:t>Öncü AI modeli</a:t>
+              <a:t>Claude · ChatGPT</a:t>
             </a:r>
           </a:p>
         </p:txBody>
@@ -11153,7 +11153,7 @@
                 </a:solidFill>
                 <a:latin typeface="Avenir Next"/>
               </a:rPr>
-              <a:t>Yerel denetçi maskeli kopyayı okur: temiz mi? Değilse bir onarım turu yapar.</a:t>
+              <a:t>Lokal LLM maskelenmiş kopyayı okur: temiz mi? Değilse bir onarım turu yapar.</a:t>
             </a:r>
           </a:p>
         </p:txBody>
@@ -11327,7 +11327,7 @@
                 </a:solidFill>
                 <a:latin typeface="Avenir Next"/>
               </a:rPr>
-              <a:t>Emin değilse, karar bir insana gider</a:t>
+              <a:t>Emin değilse, karar kullanıcının</a:t>
             </a:r>
           </a:p>
         </p:txBody>
@@ -11397,7 +11397,7 @@
                 </a:solidFill>
                 <a:latin typeface="Avenir Next"/>
               </a:rPr>
-              <a:t>Belge inceleme ekranında bir uzmanın önüne düşer — belirsizlikte son sözü her zaman insan söyler.</a:t>
+              <a:t>Belge inceleme ekranına düşer — belirsizlikte son söz her zaman kullanıcının.</a:t>
             </a:r>
           </a:p>
         </p:txBody>
@@ -12236,7 +12236,7 @@
                 </a:solidFill>
                 <a:latin typeface="Avenir Next"/>
               </a:rPr>
-              <a:t>Kişisel veri tarama motoru. Kural tabanlı kalıplar ile yapay zekâ tabanlı varlık tanımayı birlikte kullanır.</a:t>
+              <a:t>Hassas bilgi tarama motoru. Kural tabanlı kalıplar ile yapay zekâ tabanlı varlık tanımayı birlikte kullanır.</a:t>
             </a:r>
           </a:p>
         </p:txBody>
@@ -12271,7 +12271,7 @@
                 </a:solidFill>
                 <a:latin typeface="Avenir Next"/>
               </a:rPr>
-              <a:t>TC kimlik (doğrulama algoritmasıyla), IBAN, GSM, plaka, pasaport için Türkiye'ye özgü tanıyıcıları biz ekledik.</a:t>
+              <a:t>TC kimlik (doğrulama algoritmasıyla), VKN, IBAN, GSM, plaka, pasaport için Türkiye'ye özgü tanıyıcıları biz ekledik.</a:t>
             </a:r>
           </a:p>
         </p:txBody>
@@ -12616,7 +12616,7 @@
                 </a:solidFill>
                 <a:latin typeface="Avenir Next"/>
               </a:rPr>
-              <a:t>② Yerel denetçi</a:t>
+              <a:t>② Lokal LLM denetçisi</a:t>
             </a:r>
           </a:p>
         </p:txBody>
@@ -12721,7 +12721,7 @@
                 </a:solidFill>
                 <a:latin typeface="Avenir Next"/>
               </a:rPr>
-              <a:t>Ollama ile bu bilgisayarda çalışır, internete bağlanmaz. Denetçi çalışmadıysa ya da temiz demediyse belge kendiliğinden onaylanmaz — insana gider.</a:t>
+              <a:t>Ollama ile bu bilgisayarda çalışır, internete bağlanmaz. Denetçi çalışmadıysa ya da temiz demediyse belge kendiliğinden onaylanmaz — karar kullanıcıya kalır.</a:t>
             </a:r>
           </a:p>
         </p:txBody>
@@ -13423,7 +13423,7 @@
                 </a:solidFill>
                 <a:latin typeface="Avenir Next"/>
               </a:rPr>
-              <a:t>Mapping modu</a:t>
+              <a:t>Takma ad modu</a:t>
             </a:r>
           </a:p>
         </p:txBody>
@@ -13772,7 +13772,7 @@
                 </a:solidFill>
                 <a:latin typeface="Avenir Next"/>
               </a:rPr>
-              <a:t>Destructive modu</a:t>
+              <a:t>Geri döndürülemez mod</a:t>
             </a:r>
           </a:p>
         </p:txBody>
@@ -14325,23 +14325,7 @@
                 </a:solidFill>
                 <a:latin typeface="Menlo"/>
               </a:rPr>
-              <a:t>Sayın Ahmet Yılmaz, 15 Mart 2024 tarihli</a:t>
-            </a:r>
-          </a:p>
-          <a:p>
-            <a:pPr>
-              <a:spcAft>
-                <a:spcPts val="100"/>
-              </a:spcAft>
-            </a:pPr>
-            <a:r>
-              <a:rPr sz="1000" b="0">
-                <a:solidFill>
-                  <a:srgbClr val="1C1B18"/>
-                </a:solidFill>
-                <a:latin typeface="Menlo"/>
-              </a:rPr>
-              <a:t>başvurunuz değerlendirilmiştir.</a:t>
+              <a:t>Tedarik sözleşmesi</a:t>
             </a:r>
           </a:p>
           <a:p>
@@ -14370,7 +14354,7 @@
                 </a:solidFill>
                 <a:latin typeface="Menlo"/>
               </a:rPr>
-              <a:t>Müşteri adı:    Ahmet Yılmaz</a:t>
+              <a:t>Müşteri:   Örnek Lojistik A.Ş.</a:t>
             </a:r>
           </a:p>
           <a:p>
@@ -14386,7 +14370,7 @@
                 </a:solidFill>
                 <a:latin typeface="Menlo"/>
               </a:rPr>
-              <a:t>TC Kimlik No:   10203040550</a:t>
+              <a:t>Yetkili:   Ahmet Yılmaz</a:t>
             </a:r>
           </a:p>
           <a:p>
@@ -14402,7 +14386,7 @@
                 </a:solidFill>
                 <a:latin typeface="Menlo"/>
               </a:rPr>
-              <a:t>Cep telefonu:   0532 764 21 09</a:t>
+              <a:t>E-posta:   a.yilmaz@ornek.com.tr</a:t>
             </a:r>
           </a:p>
           <a:p>
@@ -14418,7 +14402,7 @@
                 </a:solidFill>
                 <a:latin typeface="Menlo"/>
               </a:rPr>
-              <a:t>E-posta:        ahmet.yilmaz@ornekposta.com</a:t>
+              <a:t>IBAN:      TR33 0006 1005 1978 6457 8413 26</a:t>
             </a:r>
           </a:p>
           <a:p>
@@ -14434,7 +14418,7 @@
                 </a:solidFill>
                 <a:latin typeface="Menlo"/>
               </a:rPr>
-              <a:t>IBAN:           TR84 0009 1000 8765 4321 0987 65</a:t>
+              <a:t>VKN:       1234567890</a:t>
             </a:r>
           </a:p>
           <a:p>
@@ -14450,7 +14434,7 @@
                 </a:solidFill>
                 <a:latin typeface="Menlo"/>
               </a:rPr>
-              <a:t>Adres:          Bağdat Caddesi No 145 Kadıköy</a:t>
+              <a:t>Tutar:     2.400.000 TL</a:t>
             </a:r>
           </a:p>
           <a:p>
@@ -14479,23 +14463,7 @@
                 </a:solidFill>
                 <a:latin typeface="Menlo"/>
               </a:rPr>
-              <a:t>İlgili sözleşme Ahmet Yılmaz tarafından</a:t>
-            </a:r>
-          </a:p>
-          <a:p>
-            <a:pPr>
-              <a:spcAft>
-                <a:spcPts val="100"/>
-              </a:spcAft>
-            </a:pPr>
-            <a:r>
-              <a:rPr sz="1000" b="0">
-                <a:solidFill>
-                  <a:srgbClr val="1C1B18"/>
-                </a:solidFill>
-                <a:latin typeface="Menlo"/>
-              </a:rPr>
-              <a:t>imzalanmıştır.</a:t>
+              <a:t>Onaylayan: A. Yılmaz</a:t>
             </a:r>
           </a:p>
         </p:txBody>
@@ -14618,23 +14586,7 @@
                 </a:solidFill>
                 <a:latin typeface="Menlo"/>
               </a:rPr>
-              <a:t>Sayın &lt;PERSON_1&gt;, 15 Mart 2024 tarihli</a:t>
-            </a:r>
-          </a:p>
-          <a:p>
-            <a:pPr>
-              <a:spcAft>
-                <a:spcPts val="100"/>
-              </a:spcAft>
-            </a:pPr>
-            <a:r>
-              <a:rPr sz="1000" b="0">
-                <a:solidFill>
-                  <a:srgbClr val="1C1B18"/>
-                </a:solidFill>
-                <a:latin typeface="Menlo"/>
-              </a:rPr>
-              <a:t>başvurunuz değerlendirilmiştir.</a:t>
+              <a:t>Tedarik sözleşmesi</a:t>
             </a:r>
           </a:p>
           <a:p>
@@ -14663,7 +14615,7 @@
                 </a:solidFill>
                 <a:latin typeface="Menlo"/>
               </a:rPr>
-              <a:t>Müşteri adı:    &lt;PERSON_1&gt;</a:t>
+              <a:t>Müşteri:   &lt;ORG_1&gt;</a:t>
             </a:r>
           </a:p>
           <a:p>
@@ -14679,7 +14631,7 @@
                 </a:solidFill>
                 <a:latin typeface="Menlo"/>
               </a:rPr>
-              <a:t>TC Kimlik No:   &lt;TCKN_1&gt;</a:t>
+              <a:t>Yetkili:   &lt;PERSON_1&gt;</a:t>
             </a:r>
           </a:p>
           <a:p>
@@ -14695,7 +14647,7 @@
                 </a:solidFill>
                 <a:latin typeface="Menlo"/>
               </a:rPr>
-              <a:t>Cep telefonu:   &lt;PHONE_1&gt;</a:t>
+              <a:t>E-posta:   &lt;EMAIL_1&gt;</a:t>
             </a:r>
           </a:p>
           <a:p>
@@ -14711,7 +14663,7 @@
                 </a:solidFill>
                 <a:latin typeface="Menlo"/>
               </a:rPr>
-              <a:t>E-posta:        &lt;EMAIL_1&gt;</a:t>
+              <a:t>IBAN:      &lt;IBAN_1&gt;</a:t>
             </a:r>
           </a:p>
           <a:p>
@@ -14727,7 +14679,7 @@
                 </a:solidFill>
                 <a:latin typeface="Menlo"/>
               </a:rPr>
-              <a:t>IBAN:           &lt;IBAN_1&gt;</a:t>
+              <a:t>VKN:       &lt;VKN_1&gt;</a:t>
             </a:r>
           </a:p>
           <a:p>
@@ -14743,7 +14695,7 @@
                 </a:solidFill>
                 <a:latin typeface="Menlo"/>
               </a:rPr>
-              <a:t>Adres:          &lt;LOCATION_1&gt;</a:t>
+              <a:t>Tutar:     2.400.000 TL</a:t>
             </a:r>
           </a:p>
           <a:p>
@@ -14772,23 +14724,7 @@
                 </a:solidFill>
                 <a:latin typeface="Menlo"/>
               </a:rPr>
-              <a:t>İlgili sözleşme &lt;PERSON_1&gt; tarafından</a:t>
-            </a:r>
-          </a:p>
-          <a:p>
-            <a:pPr>
-              <a:spcAft>
-                <a:spcPts val="100"/>
-              </a:spcAft>
-            </a:pPr>
-            <a:r>
-              <a:rPr sz="1000" b="0">
-                <a:solidFill>
-                  <a:srgbClr val="1C1B18"/>
-                </a:solidFill>
-                <a:latin typeface="Menlo"/>
-              </a:rPr>
-              <a:t>imzalanmıştır.</a:t>
+              <a:t>Onaylayan: &lt;PERSON_2&gt;</a:t>
             </a:r>
           </a:p>
         </p:txBody>
@@ -14859,7 +14795,7 @@
                 </a:solidFill>
                 <a:latin typeface="Avenir Next"/>
               </a:rPr>
-              <a:t>Aynı kişi aynı etikete dönüşür (&lt;PERSON_1&gt;); hitap ve alan adları açık kalır — metin okunur, kişi tanınmaz.</a:t>
+              <a:t>Müşteri, yetkili, e-posta, IBAN ve VKN etikete dönüşür; alan adları ve tutar açık kalır — metin okunur, taraflar tanınmaz.</a:t>
             </a:r>
           </a:p>
         </p:txBody>
@@ -15606,7 +15542,7 @@
                 </a:solidFill>
                 <a:latin typeface="Avenir Next"/>
               </a:rPr>
-              <a:t>Bekleyen karar varken onay yok; belge değiştiyse yerel denetçi yeniden okur.</a:t>
+              <a:t>Bekleyen karar varken onay yok; belge değiştiyse lokal LLM yeniden okur.</a:t>
             </a:r>
           </a:p>
         </p:txBody>

</xml_diff>